<commit_message>
System Design vi: fix review findings on sd-11-023, 024, 025
- 023: open constraint so the day-2 failure is a real build break; go.mod vs go.sum
- 024: four layers that complement each other, not a progression (title, figure, deck, README)
- 025: configuration management is not manual or imperative; distinguish by scope

Co-Authored-By: Claude Sonnet 5.5 <noreply@anthropic.com>
Claude-Session: https://claude.ai/code/session_01FUEjJx1iJbs8YafmDVXup4
</commit_message>
<xml_diff>
--- a/system-design-101/vi/lessons/sd-11-023/slides/sd-11-023.pptx
+++ b/system-design-101/vi/lessons/sd-11-023/slides/sd-11-023.pptx
@@ -5865,8 +5865,8 @@
             <a:tbl>
               <a:tblPr/>
               <a:tblGrid>
-                <a:gridCol w="6583680"/>
-                <a:gridCol w="9875520"/>
+                <a:gridCol w="3291840"/>
+                <a:gridCol w="13167360"/>
               </a:tblGrid>
               <a:tr h="1047750">
                 <a:tc>
@@ -5876,12 +5876,12 @@
                     <a:p>
                       <a:pPr algn="l" indent="0" marL="0">
                         <a:lnSpc>
-                          <a:spcPts val="3600"/>
+                          <a:spcPts val="3240"/>
                         </a:lnSpc>
                         <a:buNone/>
                       </a:pPr>
                       <a:r>
-                        <a:rPr lang="en-US" sz="3000" b="1" dirty="0" spc="-10" kern="0">
+                        <a:rPr lang="en-US" sz="2700" b="1" dirty="0" spc="-5" kern="0">
                           <a:solidFill>
                             <a:srgbClr val="FFFFFF"/>
                           </a:solidFill>
@@ -5892,7 +5892,7 @@
                         <a:t>Công</a:t>
                       </a:r>
                       <a:r>
-                        <a:rPr lang="en-US" sz="3000" b="1" dirty="0" spc="2" kern="0">
+                        <a:rPr lang="en-US" sz="2700" b="1" dirty="0" spc="-2" kern="0">
                           <a:solidFill>
                             <a:srgbClr val="FFFFFF"/>
                           </a:solidFill>
@@ -5936,12 +5936,12 @@
                     <a:p>
                       <a:pPr algn="l" indent="0" marL="0">
                         <a:lnSpc>
-                          <a:spcPts val="3600"/>
+                          <a:spcPts val="3240"/>
                         </a:lnSpc>
                         <a:buNone/>
                       </a:pPr>
                       <a:r>
-                        <a:rPr lang="en-US" sz="3000" b="1" dirty="0" spc="5" kern="0">
+                        <a:rPr lang="en-US" sz="2700" b="1" dirty="0" spc="7" kern="0">
                           <a:solidFill>
                             <a:srgbClr val="FFFFFF"/>
                           </a:solidFill>
@@ -5952,7 +5952,7 @@
                         <a:t>Cách</a:t>
                       </a:r>
                       <a:r>
-                        <a:rPr lang="en-US" sz="3000" b="1" dirty="0" spc="-9" kern="0">
+                        <a:rPr lang="en-US" sz="2700" b="1" dirty="0" spc="-10" kern="0">
                           <a:solidFill>
                             <a:srgbClr val="FFFFFF"/>
                           </a:solidFill>
@@ -6004,12 +6004,12 @@
                     <a:p>
                       <a:pPr algn="l" indent="0" marL="0">
                         <a:lnSpc>
-                          <a:spcPts val="3600"/>
+                          <a:spcPts val="3240"/>
                         </a:lnSpc>
                         <a:buNone/>
                       </a:pPr>
                       <a:r>
-                        <a:rPr lang="en-US" sz="3000" b="1" dirty="0" spc="-7" kern="0">
+                        <a:rPr lang="en-US" sz="2700" b="1" dirty="0" spc="-5" kern="0">
                           <a:solidFill>
                             <a:srgbClr val="000000"/>
                           </a:solidFill>
@@ -6059,12 +6059,12 @@
                     <a:p>
                       <a:pPr algn="l" indent="0" marL="0">
                         <a:lnSpc>
-                          <a:spcPts val="3600"/>
+                          <a:spcPts val="3240"/>
                         </a:lnSpc>
                         <a:buNone/>
                       </a:pPr>
                       <a:r>
-                        <a:rPr lang="en-US" sz="3000" dirty="0" spc="-87" kern="0">
+                        <a:rPr lang="en-US" sz="2700" dirty="0" spc="-82" kern="0">
                           <a:solidFill>
                             <a:srgbClr val="000000"/>
                           </a:solidFill>
@@ -6075,7 +6075,7 @@
                         <a:t>Tệp</a:t>
                       </a:r>
                       <a:r>
-                        <a:rPr lang="en-US" sz="3000" dirty="0" spc="-1" kern="0">
+                        <a:rPr lang="en-US" sz="2700" dirty="0" spc="-5" kern="0">
                           <a:solidFill>
                             <a:srgbClr val="000000"/>
                           </a:solidFill>
@@ -6133,12 +6133,12 @@
                     <a:p>
                       <a:pPr algn="l" indent="0" marL="0">
                         <a:lnSpc>
-                          <a:spcPts val="3600"/>
+                          <a:spcPts val="3240"/>
                         </a:lnSpc>
                         <a:buNone/>
                       </a:pPr>
                       <a:r>
-                        <a:rPr lang="en-US" sz="3000" b="1" dirty="0" spc="-3" kern="0">
+                        <a:rPr lang="en-US" sz="2700" b="1" dirty="0" spc="-1" kern="0">
                           <a:solidFill>
                             <a:srgbClr val="000000"/>
                           </a:solidFill>
@@ -6188,12 +6188,12 @@
                     <a:p>
                       <a:pPr algn="l" indent="0" marL="0">
                         <a:lnSpc>
-                          <a:spcPts val="3600"/>
+                          <a:spcPts val="3240"/>
                         </a:lnSpc>
                         <a:buNone/>
                       </a:pPr>
                       <a:r>
-                        <a:rPr lang="en-US" sz="3000" dirty="0" spc="-87" kern="0">
+                        <a:rPr lang="en-US" sz="2700" dirty="0" spc="-14" kern="0">
                           <a:solidFill>
                             <a:srgbClr val="000000"/>
                           </a:solidFill>
@@ -6201,10 +6201,10 @@
                           <a:ea typeface="Be Vietnam Pro" pitchFamily="34" charset="-122"/>
                           <a:cs typeface="Be Vietnam Pro" pitchFamily="34" charset="-120"/>
                         </a:rPr>
-                        <a:t>Tệp</a:t>
+                        <a:t>go.mod</a:t>
                       </a:r>
                       <a:r>
-                        <a:rPr lang="en-US" sz="3000" dirty="0" spc="-12" kern="0">
+                        <a:rPr lang="en-US" sz="2700" dirty="0" spc="-1" kern="0">
                           <a:solidFill>
                             <a:srgbClr val="000000"/>
                           </a:solidFill>
@@ -6212,10 +6212,10 @@
                           <a:ea typeface="Be Vietnam Pro" pitchFamily="34" charset="-122"/>
                           <a:cs typeface="Be Vietnam Pro" pitchFamily="34" charset="-120"/>
                         </a:rPr>
-                        <a:t> tổng</a:t>
+                        <a:t> ghi</a:t>
                       </a:r>
                       <a:r>
-                        <a:rPr lang="en-US" sz="3000" dirty="0" spc="3" kern="0">
+                        <a:rPr lang="en-US" sz="2700" dirty="0" spc="-3" kern="0">
                           <a:solidFill>
                             <a:srgbClr val="000000"/>
                           </a:solidFill>
@@ -6223,7 +6223,51 @@
                           <a:ea typeface="Be Vietnam Pro" pitchFamily="34" charset="-122"/>
                           <a:cs typeface="Be Vietnam Pro" pitchFamily="34" charset="-120"/>
                         </a:rPr>
-                        <a:t> kiểm</a:t>
+                        <a:t> phiên bản;</a:t>
+                      </a:r>
+                      <a:r>
+                        <a:rPr lang="en-US" sz="2700" dirty="0" spc="-10" kern="0">
+                          <a:solidFill>
+                            <a:srgbClr val="000000"/>
+                          </a:solidFill>
+                          <a:latin typeface="Be Vietnam Pro" pitchFamily="34" charset="0"/>
+                          <a:ea typeface="Be Vietnam Pro" pitchFamily="34" charset="-122"/>
+                          <a:cs typeface="Be Vietnam Pro" pitchFamily="34" charset="-120"/>
+                        </a:rPr>
+                        <a:t> go.sum</a:t>
+                      </a:r>
+                      <a:r>
+                        <a:rPr lang="en-US" sz="2700" dirty="0" spc="-1" kern="0">
+                          <a:solidFill>
+                            <a:srgbClr val="000000"/>
+                          </a:solidFill>
+                          <a:latin typeface="Be Vietnam Pro" pitchFamily="34" charset="0"/>
+                          <a:ea typeface="Be Vietnam Pro" pitchFamily="34" charset="-122"/>
+                          <a:cs typeface="Be Vietnam Pro" pitchFamily="34" charset="-120"/>
+                        </a:rPr>
+                        <a:t> chỉ ghi</a:t>
+                      </a:r>
+                      <a:r>
+                        <a:rPr lang="en-US" sz="2700" dirty="0" spc="-2" kern="0">
+                          <a:solidFill>
+                            <a:srgbClr val="000000"/>
+                          </a:solidFill>
+                          <a:latin typeface="Be Vietnam Pro" pitchFamily="34" charset="0"/>
+                          <a:ea typeface="Be Vietnam Pro" pitchFamily="34" charset="-122"/>
+                          <a:cs typeface="Be Vietnam Pro" pitchFamily="34" charset="-120"/>
+                        </a:rPr>
+                        <a:t> mã</a:t>
+                      </a:r>
+                      <a:r>
+                        <a:rPr lang="en-US" sz="2700" dirty="0" spc="-5" kern="0">
+                          <a:solidFill>
+                            <a:srgbClr val="000000"/>
+                          </a:solidFill>
+                          <a:latin typeface="Be Vietnam Pro" pitchFamily="34" charset="0"/>
+                          <a:ea typeface="Be Vietnam Pro" pitchFamily="34" charset="-122"/>
+                          <a:cs typeface="Be Vietnam Pro" pitchFamily="34" charset="-120"/>
+                        </a:rPr>
+                        <a:t> băm</a:t>
                       </a:r>
                       <a:endParaRPr lang="en-US" sz="1200" dirty="0"/>
                     </a:p>
@@ -6273,12 +6317,12 @@
                     <a:p>
                       <a:pPr algn="l" indent="0" marL="0">
                         <a:lnSpc>
-                          <a:spcPts val="3600"/>
+                          <a:spcPts val="3240"/>
                         </a:lnSpc>
                         <a:buNone/>
                       </a:pPr>
                       <a:r>
-                        <a:rPr lang="en-US" sz="3000" b="1" dirty="0" spc="-18" kern="0">
+                        <a:rPr lang="en-US" sz="2700" b="1" dirty="0" spc="-14" kern="0">
                           <a:solidFill>
                             <a:srgbClr val="000000"/>
                           </a:solidFill>
@@ -6328,12 +6372,12 @@
                     <a:p>
                       <a:pPr algn="l" indent="0" marL="0">
                         <a:lnSpc>
-                          <a:spcPts val="3600"/>
+                          <a:spcPts val="3240"/>
                         </a:lnSpc>
                         <a:buNone/>
                       </a:pPr>
                       <a:r>
-                        <a:rPr lang="en-US" sz="3000" dirty="0" spc="-87" kern="0">
+                        <a:rPr lang="en-US" sz="2700" dirty="0" spc="-82" kern="0">
                           <a:solidFill>
                             <a:srgbClr val="000000"/>
                           </a:solidFill>
@@ -6344,7 +6388,7 @@
                         <a:t>Tệp</a:t>
                       </a:r>
                       <a:r>
-                        <a:rPr lang="en-US" sz="3000" dirty="0" spc="-1" kern="0">
+                        <a:rPr lang="en-US" sz="2700" dirty="0" spc="-5" kern="0">
                           <a:solidFill>
                             <a:srgbClr val="000000"/>
                           </a:solidFill>
@@ -6402,12 +6446,12 @@
                     <a:p>
                       <a:pPr algn="l" indent="0" marL="0">
                         <a:lnSpc>
-                          <a:spcPts val="3600"/>
+                          <a:spcPts val="3240"/>
                         </a:lnSpc>
                         <a:buNone/>
                       </a:pPr>
                       <a:r>
-                        <a:rPr lang="en-US" sz="3000" b="1" dirty="0" spc="-5" kern="0">
+                        <a:rPr lang="en-US" sz="2700" b="1" dirty="0" spc="-4" kern="0">
                           <a:solidFill>
                             <a:srgbClr val="000000"/>
                           </a:solidFill>
@@ -6457,12 +6501,12 @@
                     <a:p>
                       <a:pPr algn="l" indent="0" marL="0">
                         <a:lnSpc>
-                          <a:spcPts val="3600"/>
+                          <a:spcPts val="3240"/>
                         </a:lnSpc>
                         <a:buNone/>
                       </a:pPr>
                       <a:r>
-                        <a:rPr lang="en-US" sz="3000" dirty="0" spc="-87" kern="0">
+                        <a:rPr lang="en-US" sz="2700" dirty="0" spc="2" kern="0">
                           <a:solidFill>
                             <a:srgbClr val="000000"/>
                           </a:solidFill>
@@ -6470,10 +6514,10 @@
                           <a:ea typeface="Be Vietnam Pro" pitchFamily="34" charset="-122"/>
                           <a:cs typeface="Be Vietnam Pro" pitchFamily="34" charset="-120"/>
                         </a:rPr>
-                        <a:t>Tệp</a:t>
+                        <a:t>Cách</a:t>
                       </a:r>
                       <a:r>
-                        <a:rPr lang="en-US" sz="3000" dirty="0" spc="-1" kern="0">
+                        <a:rPr lang="en-US" sz="2700" dirty="0" spc="-4" kern="0">
                           <a:solidFill>
                             <a:srgbClr val="000000"/>
                           </a:solidFill>
@@ -6481,7 +6525,18 @@
                           <a:ea typeface="Be Vietnam Pro" pitchFamily="34" charset="-122"/>
                           <a:cs typeface="Be Vietnam Pro" pitchFamily="34" charset="-120"/>
                         </a:rPr>
-                        <a:t> khóa</a:t>
+                        <a:t> chốt</a:t>
+                      </a:r>
+                      <a:r>
+                        <a:rPr lang="en-US" sz="2700" dirty="0" spc="6" kern="0">
+                          <a:solidFill>
+                            <a:srgbClr val="000000"/>
+                          </a:solidFill>
+                          <a:latin typeface="Be Vietnam Pro" pitchFamily="34" charset="0"/>
+                          <a:ea typeface="Be Vietnam Pro" pitchFamily="34" charset="-122"/>
+                          <a:cs typeface="Be Vietnam Pro" pitchFamily="34" charset="-120"/>
+                        </a:rPr>
+                        <a:t> riêng</a:t>
                       </a:r>
                       <a:endParaRPr lang="en-US" sz="1200" dirty="0"/>
                     </a:p>
@@ -7726,7 +7781,7 @@
               <a:t> 2.0,</a:t>
             </a:r>
             <a:r>
-              <a:rPr lang="en-US" sz="2550" dirty="0" spc="0" kern="0">
+              <a:rPr lang="en-US" sz="2550" dirty="0" spc="-2" kern="0">
                 <a:solidFill>
                   <a:srgbClr val="14161C"/>
                 </a:solidFill>
@@ -7734,10 +7789,10 @@
                 <a:ea typeface="Be Vietnam Pro SemiBold" pitchFamily="34" charset="-122"/>
                 <a:cs typeface="Be Vietnam Pro SemiBold" pitchFamily="34" charset="-120"/>
               </a:rPr>
-              <a:t> vi</a:t>
-            </a:r>
-            <a:r>
-              <a:rPr lang="en-US" sz="2550" dirty="0" spc="-4" kern="0">
+              <a:t> hợp</a:t>
+            </a:r>
+            <a:r>
+              <a:rPr lang="en-US" sz="2550" dirty="0" spc="-15" kern="0">
                 <a:solidFill>
                   <a:srgbClr val="14161C"/>
                 </a:solidFill>
@@ -7745,10 +7800,10 @@
                 <a:ea typeface="Be Vietnam Pro SemiBold" pitchFamily="34" charset="-122"/>
                 <a:cs typeface="Be Vietnam Pro SemiBold" pitchFamily="34" charset="-120"/>
               </a:rPr>
-              <a:t> phạm</a:t>
-            </a:r>
-            <a:r>
-              <a:rPr lang="en-US" sz="2550" dirty="0" spc="-15" kern="0">
+              <a:t> ràng</a:t>
+            </a:r>
+            <a:r>
+              <a:rPr lang="en-US" sz="2550" dirty="0" spc="-4" kern="0">
                 <a:solidFill>
                   <a:srgbClr val="14161C"/>
                 </a:solidFill>
@@ -7756,10 +7811,10 @@
                 <a:ea typeface="Be Vietnam Pro SemiBold" pitchFamily="34" charset="-122"/>
                 <a:cs typeface="Be Vietnam Pro SemiBold" pitchFamily="34" charset="-120"/>
               </a:rPr>
-              <a:t> ràng</a:t>
-            </a:r>
-            <a:r>
-              <a:rPr lang="en-US" sz="2550" dirty="0" spc="-4" kern="0">
+              <a:t> buộc</a:t>
+            </a:r>
+            <a:r>
+              <a:rPr lang="en-US" sz="2550" dirty="0" spc="22" kern="0">
                 <a:solidFill>
                   <a:srgbClr val="14161C"/>
                 </a:solidFill>
@@ -7767,7 +7822,18 @@
                 <a:ea typeface="Be Vietnam Pro SemiBold" pitchFamily="34" charset="-122"/>
                 <a:cs typeface="Be Vietnam Pro SemiBold" pitchFamily="34" charset="-120"/>
               </a:rPr>
-              <a:t> buộc</a:t>
+              <a:t> nhưng</a:t>
+            </a:r>
+            <a:r>
+              <a:rPr lang="en-US" sz="2550" dirty="0" spc="-4" kern="0">
+                <a:solidFill>
+                  <a:srgbClr val="14161C"/>
+                </a:solidFill>
+                <a:latin typeface="Be Vietnam Pro SemiBold" pitchFamily="34" charset="0"/>
+                <a:ea typeface="Be Vietnam Pro SemiBold" pitchFamily="34" charset="-122"/>
+                <a:cs typeface="Be Vietnam Pro SemiBold" pitchFamily="34" charset="-120"/>
+              </a:rPr>
+              <a:t> A hỏng</a:t>
             </a:r>
             <a:endParaRPr lang="en-US" sz="2550" dirty="0"/>
           </a:p>

</xml_diff>